<commit_message>
Actualizar Excel, PowerPoint y diagramas con los datos del informe
Co-Authored-By: Claude Opus 5.5 <noreply@anthropic.com>
Claude-Session: https://claude.ai/code/session_01P9bj8o7UcwbCu86Zsog7Lb
</commit_message>
<xml_diff>
--- a/Actividad Alva instructora Luna de Cristal/4_Paso4_Visual_Thinking.pptx
+++ b/Actividad Alva instructora Luna de Cristal/4_Paso4_Visual_Thinking.pptx
@@ -115,31 +115,31 @@
   <p:extLst>
     <p:ext uri="{521415D9-36F7-43E2-AB2F-B90AF26B5E84}">
       <p14:sectionLst xmlns:p14="http://schemas.microsoft.com/office/powerpoint/2010/main">
-        <p14:section name="Inicio" id="{64f373d1-e5ab-c738-c8b5-7e9c4fd6022d}">
+        <p14:section name="Inicio" id="{69b68b68-ca8a-b276-f5aa-2a8647f7a240}">
           <p14:sldIdLst>
             <p14:sldId id="256"/>
           </p14:sldIdLst>
         </p14:section>
-        <p14:section name="Diagnóstico" id="{d6bf0132-e216-005c-7c11-7019a29374ed}">
+        <p14:section name="Diagnóstico" id="{530b8d97-0ee3-dd76-aded-0ffe4011b801}">
           <p14:sldIdLst>
             <p14:sldId id="257"/>
             <p14:sldId id="258"/>
             <p14:sldId id="259"/>
           </p14:sldIdLst>
         </p14:section>
-        <p14:section name="Análisis" id="{abf291d7-2c31-3c29-53fa-64a38714eb5a}">
+        <p14:section name="Análisis" id="{8f34badc-0161-5319-3a90-164cb64e769f}">
           <p14:sldIdLst>
             <p14:sldId id="260"/>
             <p14:sldId id="261"/>
           </p14:sldIdLst>
         </p14:section>
-        <p14:section name="Innovación" id="{ccc0a77b-8f4d-8dde-434a-db2c816c570c}">
+        <p14:section name="Innovación" id="{f930c74a-f58e-4618-575c-133779c61825}">
           <p14:sldIdLst>
             <p14:sldId id="262"/>
             <p14:sldId id="263"/>
           </p14:sldIdLst>
         </p14:section>
-        <p14:section name="Cierre" id="{dd028035-f734-153e-e87b-d2d3ab7949ef}">
+        <p14:section name="Cierre" id="{7de344fe-abe8-9714-ea92-4364f567840b}">
           <p14:sldIdLst>
             <p14:sldId id="264"/>
           </p14:sldIdLst>
@@ -812,7 +812,7 @@
           <a:p>
             <a:r>
               <a:rPr lang="en-US" dirty="0"/>
-              <a:t>Clasifiqué los procesos en estratégicos, misionales y de apoyo. En los tres encontré lo mismo: funcionan de manera informal y sin registros.</a:t>
+              <a:t>Clasifiqué los procesos en estratégicos, misionales y de apoyo. La atención es la gran fortaleza, pero inventario, ventas y facturación se llevan a mano, sin sistema POS.</a:t>
             </a:r>
             <a:endParaRPr lang="en-US" dirty="0"/>
           </a:p>
@@ -900,7 +900,7 @@
           <a:p>
             <a:r>
               <a:rPr lang="en-US" dirty="0"/>
-              <a:t>El efecto es que las ventas están por debajo de su potencial. La mayoría de las causas están en comunicación, procesos y medición, y se pueden corregir con poca inversión.</a:t>
+              <a:t>El efecto es que las ventas están por debajo de su potencial. Las causas más fuertes son el bajo alcance en redes, los procesos manuales y la falta de datos; casi todas se pueden corregir con poca inversión.</a:t>
             </a:r>
             <a:endParaRPr lang="en-US" dirty="0"/>
           </a:p>
@@ -988,7 +988,7 @@
           <a:p>
             <a:r>
               <a:rPr lang="en-US" dirty="0"/>
-              <a:t>Los clientes internos necesitan apoyo y datos; las clientas necesitan ver los productos antes de ir y que les respondan rápido.</a:t>
+              <a:t>Los colaboradores piden mejorar la tecnología, las clientas valoran estilo, precio y atención y compran cada vez más por redes, y los proveedores piden más retroalimentación.</a:t>
             </a:r>
             <a:endParaRPr lang="en-US" dirty="0"/>
           </a:p>
@@ -1975,7 +1975,7 @@
                   <a:schemeClr val="bg2"/>
                 </a:solidFill>
               </a:rPr>
-              <a:t>Aprendiz: Sebastián [apellidos] · Instructora: Alva [apellidos]</a:t>
+              <a:t>Aprendiz: Eimer Sebastián Rojas Cañas · Instructora: Alba Rocío Cuchigay Rosas</a:t>
             </a:r>
             <a:endParaRPr lang="en-US" sz="2000" dirty="0"/>
           </a:p>
@@ -1989,7 +1989,7 @@
                   <a:schemeClr val="bg2"/>
                 </a:solidFill>
               </a:rPr>
-              <a:t>SENA · Yopal, Casanare · Octubre 2026</a:t>
+              <a:t>SENA · Tecnólogo en Gestión del Desarrollo Administrativo e Innovación · Yopal 2026</a:t>
             </a:r>
             <a:endParaRPr lang="en-US" sz="2000" dirty="0"/>
           </a:p>
@@ -2296,7 +2296,7 @@
                 <a:ea typeface="Calibri" pitchFamily="34" charset="-122"/>
                 <a:cs typeface="Calibri" pitchFamily="34" charset="-120"/>
               </a:rPr>
-              <a:t>Tienda familiar en Yopal</a:t>
+              <a:t>Microempresa familiar (2026)</a:t>
             </a:r>
             <a:endParaRPr lang="en-US" sz="1800" dirty="0"/>
           </a:p>
@@ -2335,7 +2335,7 @@
                 <a:ea typeface="Calibri" pitchFamily="34" charset="-122"/>
                 <a:cs typeface="Calibri" pitchFamily="34" charset="-120"/>
               </a:rPr>
-              <a:t>Local físico administrado por la dueña; registrada en Cámara de Comercio.</a:t>
+              <a:t>Cra 19 # 23-57, centro de Yopal. Propietaria y un asesor de ventas.</a:t>
             </a:r>
             <a:endParaRPr lang="en-US" sz="1400" dirty="0"/>
           </a:p>
@@ -2423,7 +2423,7 @@
                 <a:ea typeface="Calibri" pitchFamily="34" charset="-122"/>
                 <a:cs typeface="Calibri" pitchFamily="34" charset="-120"/>
               </a:rPr>
-              <a:t>Ropa para dama</a:t>
+              <a:t>Ropa, perfumes y correas</a:t>
             </a:r>
             <a:endParaRPr lang="en-US" sz="1800" dirty="0"/>
           </a:p>
@@ -2462,7 +2462,7 @@
                 <a:ea typeface="Calibri" pitchFamily="34" charset="-122"/>
                 <a:cs typeface="Calibri" pitchFamily="34" charset="-120"/>
               </a:rPr>
-              <a:t>Blusas, pantalones, vestidos y más, con asesoría personalizada.</a:t>
+              <a:t>Jeans, vestidos, faldas, shorts y bodys para mujeres de 16 a 60 años.</a:t>
             </a:r>
             <a:endParaRPr lang="en-US" sz="1400" dirty="0"/>
           </a:p>
@@ -2550,7 +2550,7 @@
                 <a:ea typeface="Calibri" pitchFamily="34" charset="-122"/>
                 <a:cs typeface="Calibri" pitchFamily="34" charset="-120"/>
               </a:rPr>
-              <a:t>Perfumes de $80.000 a $120.000</a:t>
+              <a:t>7 clientas al día</a:t>
             </a:r>
             <a:endParaRPr lang="en-US" sz="1800" dirty="0"/>
           </a:p>
@@ -2589,7 +2589,7 @@
                 <a:ea typeface="Calibri" pitchFamily="34" charset="-122"/>
                 <a:cs typeface="Calibri" pitchFamily="34" charset="-120"/>
               </a:rPr>
-              <a:t>El producto de mayor valor y mejor margen.</a:t>
+              <a:t>Vende más los viernes, sábados y fechas especiales.</a:t>
             </a:r>
             <a:endParaRPr lang="en-US" sz="1400" dirty="0"/>
           </a:p>
@@ -2856,7 +2856,7 @@
                 <a:ea typeface="Calibri" pitchFamily="34" charset="-122"/>
                 <a:cs typeface="Calibri" pitchFamily="34" charset="-120"/>
               </a:rPr>
-              <a:t>Productos de calidad y buen margen</a:t>
+              <a:t>Atención cercana y personalizada</a:t>
             </a:r>
             <a:endParaRPr lang="en-US" sz="1600" dirty="0"/>
           </a:p>
@@ -2877,7 +2877,7 @@
                 <a:ea typeface="Calibri" pitchFamily="34" charset="-122"/>
                 <a:cs typeface="Calibri" pitchFamily="34" charset="-120"/>
               </a:rPr>
-              <a:t>Local propio que genera confianza</a:t>
+              <a:t>93,3 % de las clientas la recomienda</a:t>
             </a:r>
             <a:endParaRPr lang="en-US" sz="1600" dirty="0"/>
           </a:p>
@@ -2898,7 +2898,7 @@
                 <a:ea typeface="Calibri" pitchFamily="34" charset="-122"/>
                 <a:cs typeface="Calibri" pitchFamily="34" charset="-120"/>
               </a:rPr>
-              <a:t>Atención cercana y familiar</a:t>
+              <a:t>Precios cómodos: pantalón $97.000 vs. $120.000-150.000</a:t>
             </a:r>
             <a:endParaRPr lang="en-US" sz="1600" dirty="0"/>
           </a:p>
@@ -2919,7 +2919,7 @@
                 <a:ea typeface="Calibri" pitchFamily="34" charset="-122"/>
                 <a:cs typeface="Calibri" pitchFamily="34" charset="-120"/>
               </a:rPr>
-              <a:t>Envío gratis dentro de Yopal</a:t>
+              <a:t>Ubicación céntrica</a:t>
             </a:r>
             <a:endParaRPr lang="en-US" sz="1600" dirty="0"/>
           </a:p>
@@ -2940,7 +2940,7 @@
                 <a:ea typeface="Calibri" pitchFamily="34" charset="-122"/>
                 <a:cs typeface="Calibri" pitchFamily="34" charset="-120"/>
               </a:rPr>
-              <a:t>Ropa + perfume: combos de mayor valor</a:t>
+              <a:t>Equipo motivado (100 %)</a:t>
             </a:r>
             <a:endParaRPr lang="en-US" sz="1600" dirty="0"/>
           </a:p>
@@ -2961,7 +2961,7 @@
                 <a:ea typeface="Calibri" pitchFamily="34" charset="-122"/>
                 <a:cs typeface="Calibri" pitchFamily="34" charset="-120"/>
               </a:rPr>
-              <a:t>Disposición al cambio</a:t>
+              <a:t>Proveedores satisfechos (100 % seguiría)</a:t>
             </a:r>
             <a:endParaRPr lang="en-US" sz="1600" dirty="0"/>
           </a:p>
@@ -3234,7 +3234,7 @@
                 <a:ea typeface="Calibri" pitchFamily="34" charset="-122"/>
                 <a:cs typeface="Calibri" pitchFamily="34" charset="-120"/>
               </a:rPr>
-              <a:t>Planeación de compras y temporadas</a:t>
+              <a:t>Planeación de compras</a:t>
             </a:r>
             <a:endParaRPr lang="en-US" sz="1500" dirty="0"/>
           </a:p>
@@ -3276,7 +3276,7 @@
                 <a:ea typeface="Calibri" pitchFamily="34" charset="-122"/>
                 <a:cs typeface="Calibri" pitchFamily="34" charset="-120"/>
               </a:rPr>
-              <a:t>Decisiones del negocio</a:t>
+              <a:t>Visión 2030: físico + digital</a:t>
             </a:r>
             <a:endParaRPr lang="en-US" sz="1500" dirty="0"/>
           </a:p>
@@ -3342,7 +3342,7 @@
                 <a:ea typeface="Calibri" pitchFamily="34" charset="-122"/>
                 <a:cs typeface="Calibri" pitchFamily="34" charset="-120"/>
               </a:rPr>
-              <a:t>Informales, sin datos</a:t>
+              <a:t>Sin indicadores ni plan escrito</a:t>
             </a:r>
             <a:endParaRPr lang="en-US" sz="1300" dirty="0"/>
           </a:p>
@@ -3532,7 +3532,7 @@
                 <a:ea typeface="Calibri" pitchFamily="34" charset="-122"/>
                 <a:cs typeface="Calibri" pitchFamily="34" charset="-120"/>
               </a:rPr>
-              <a:t>Compra a proveedores</a:t>
+              <a:t>Compra (Bogotá, Medellín, Shein)</a:t>
             </a:r>
             <a:endParaRPr lang="en-US" sz="1500" dirty="0"/>
           </a:p>
@@ -3574,7 +3574,7 @@
                 <a:ea typeface="Calibri" pitchFamily="34" charset="-122"/>
                 <a:cs typeface="Calibri" pitchFamily="34" charset="-120"/>
               </a:rPr>
-              <a:t>Atención y asesoría</a:t>
+              <a:t>Atención personalizada</a:t>
             </a:r>
             <a:endParaRPr lang="en-US" sz="1500" dirty="0"/>
           </a:p>
@@ -3595,7 +3595,7 @@
                 <a:ea typeface="Calibri" pitchFamily="34" charset="-122"/>
                 <a:cs typeface="Calibri" pitchFamily="34" charset="-120"/>
               </a:rPr>
-              <a:t>Venta, cobro y domicilio</a:t>
+              <a:t>Venta física, redes y domicilio</a:t>
             </a:r>
             <a:endParaRPr lang="en-US" sz="1500" dirty="0"/>
           </a:p>
@@ -3851,7 +3851,7 @@
                 <a:ea typeface="Calibri" pitchFamily="34" charset="-122"/>
                 <a:cs typeface="Calibri" pitchFamily="34" charset="-120"/>
               </a:rPr>
-              <a:t>Control de inventario</a:t>
+              <a:t>Inventario y ventas</a:t>
             </a:r>
             <a:endParaRPr lang="en-US" sz="1500" dirty="0"/>
           </a:p>
@@ -3872,7 +3872,7 @@
                 <a:ea typeface="Calibri" pitchFamily="34" charset="-122"/>
                 <a:cs typeface="Calibri" pitchFamily="34" charset="-120"/>
               </a:rPr>
-              <a:t>Caja y registro de ventas</a:t>
+              <a:t>Facturación y caja</a:t>
             </a:r>
             <a:endParaRPr lang="en-US" sz="1500" dirty="0"/>
           </a:p>
@@ -3893,7 +3893,7 @@
                 <a:ea typeface="Calibri" pitchFamily="34" charset="-122"/>
                 <a:cs typeface="Calibri" pitchFamily="34" charset="-120"/>
               </a:rPr>
-              <a:t>Redes sociales y WhatsApp</a:t>
+              <a:t>Redes y Meta Ads</a:t>
             </a:r>
             <a:endParaRPr lang="en-US" sz="1500" dirty="0"/>
           </a:p>
@@ -3914,7 +3914,7 @@
                 <a:ea typeface="Calibri" pitchFamily="34" charset="-122"/>
                 <a:cs typeface="Calibri" pitchFamily="34" charset="-120"/>
               </a:rPr>
-              <a:t>Aseo del local</a:t>
+              <a:t>Talento humano y SST</a:t>
             </a:r>
             <a:endParaRPr lang="en-US" sz="1500" dirty="0"/>
           </a:p>
@@ -3980,7 +3980,7 @@
                 <a:ea typeface="Calibri" pitchFamily="34" charset="-122"/>
                 <a:cs typeface="Calibri" pitchFamily="34" charset="-120"/>
               </a:rPr>
-              <a:t>Sin registros, redes inactivas</a:t>
+              <a:t>Todo a mano, sin POS</a:t>
             </a:r>
             <a:endParaRPr lang="en-US" sz="1300" dirty="0"/>
           </a:p>
@@ -4202,7 +4202,7 @@
                 <a:ea typeface="Calibri" pitchFamily="34" charset="-122"/>
                 <a:cs typeface="Calibri" pitchFamily="34" charset="-120"/>
               </a:rPr>
-              <a:t>El problema no es el producto: es que casi nadie conoce la tienda y no se miden los resultados.</a:t>
+              <a:t>El problema no es el producto: es el poco alcance digital y que todo se maneja a mano.</a:t>
             </a:r>
             <a:endParaRPr lang="en-US" sz="1400" dirty="0"/>
           </a:p>
@@ -4310,7 +4310,7 @@
                   <a:schemeClr val="tx2"/>
                 </a:solidFill>
               </a:rPr>
-              <a:t>Necesidades de los clientes</a:t>
+              <a:t>Necesidades de clientes y proveedores</a:t>
             </a:r>
             <a:endParaRPr lang="en-US" sz="3600" dirty="0"/>
           </a:p>
@@ -4325,11 +4325,11 @@
         <p:spPr>
           <a:xfrm>
             <a:off x="548640" y="1463040"/>
-            <a:ext cx="5394960" cy="4572000"/>
+            <a:ext cx="3520440" cy="4572000"/>
           </a:xfrm>
           <a:prstGeom prst="roundRect">
             <a:avLst>
-              <a:gd name="adj" fmla="val 2400"/>
+              <a:gd name="adj" fmla="val 3117"/>
             </a:avLst>
           </a:prstGeom>
           <a:solidFill>
@@ -4358,7 +4358,7 @@
         </p:nvSpPr>
         <p:spPr>
           <a:xfrm>
-            <a:off x="914400" y="1737360"/>
+            <a:off x="1828800" y="1691640"/>
             <a:ext cx="914400" cy="914400"/>
           </a:xfrm>
           <a:prstGeom prst="ellipse">
@@ -4391,7 +4391,7 @@
         </p:blipFill>
         <p:spPr>
           <a:xfrm>
-            <a:off x="1143000" y="1965960"/>
+            <a:off x="2057400" y="1920240"/>
             <a:ext cx="457200" cy="457200"/>
           </a:xfrm>
           <a:prstGeom prst="rect">
@@ -4407,8 +4407,8 @@
         </p:nvSpPr>
         <p:spPr>
           <a:xfrm>
-            <a:off x="2011680" y="1783080"/>
-            <a:ext cx="3657600" cy="457200"/>
+            <a:off x="548640" y="2743200"/>
+            <a:ext cx="3520440" cy="457200"/>
           </a:xfrm>
           <a:prstGeom prst="rect">
             <a:avLst/>
@@ -4420,7 +4420,7 @@
           <a:bodyPr wrap="square" lIns="0" tIns="0" rIns="0" bIns="0" rtlCol="0" anchor="t"/>
           <a:lstStyle/>
           <a:p>
-            <a:pPr indent="0" marL="0">
+            <a:pPr algn="ctr" indent="0" marL="0">
               <a:buNone/>
             </a:pPr>
             <a:r>
@@ -4432,7 +4432,7 @@
                 <a:ea typeface="Cambria" pitchFamily="34" charset="-122"/>
                 <a:cs typeface="Cambria" pitchFamily="34" charset="-120"/>
               </a:rPr>
-              <a:t>Clientes internos</a:t>
+              <a:t>Internos</a:t>
             </a:r>
             <a:endParaRPr lang="en-US" sz="2400" dirty="0"/>
           </a:p>
@@ -4446,8 +4446,8 @@
         </p:nvSpPr>
         <p:spPr>
           <a:xfrm>
-            <a:off x="2011680" y="2267712"/>
-            <a:ext cx="3657600" cy="365760"/>
+            <a:off x="548640" y="3200400"/>
+            <a:ext cx="3520440" cy="365760"/>
           </a:xfrm>
           <a:prstGeom prst="rect">
             <a:avLst/>
@@ -4459,11 +4459,11 @@
           <a:bodyPr wrap="square" lIns="0" tIns="0" rIns="0" bIns="0" rtlCol="0" anchor="t"/>
           <a:lstStyle/>
           <a:p>
-            <a:pPr indent="0" marL="0">
+            <a:pPr algn="ctr" indent="0" marL="0">
               <a:buNone/>
             </a:pPr>
             <a:r>
-              <a:rPr lang="en-US" sz="1500" i="1" dirty="0">
+              <a:rPr lang="en-US" sz="1400" i="1" dirty="0">
                 <a:solidFill>
                   <a:srgbClr val="555555"/>
                 </a:solidFill>
@@ -4471,9 +4471,9 @@
                 <a:ea typeface="Calibri" pitchFamily="34" charset="-122"/>
                 <a:cs typeface="Calibri" pitchFamily="34" charset="-120"/>
               </a:rPr>
-              <a:t>La dueña y la familia</a:t>
-            </a:r>
-            <a:endParaRPr lang="en-US" sz="1500" dirty="0"/>
+              <a:t>Propietaria y asesor</a:t>
+            </a:r>
+            <a:endParaRPr lang="en-US" sz="1400" dirty="0"/>
           </a:p>
         </p:txBody>
       </p:sp>
@@ -4485,8 +4485,8 @@
         </p:nvSpPr>
         <p:spPr>
           <a:xfrm>
-            <a:off x="1005840" y="3017520"/>
-            <a:ext cx="4572000" cy="2743200"/>
+            <a:off x="822960" y="3794760"/>
+            <a:ext cx="3017520" cy="2103120"/>
           </a:xfrm>
           <a:prstGeom prst="rect">
             <a:avLst/>
@@ -4500,13 +4500,13 @@
           <a:p>
             <a:pPr marL="342900" indent="-342900">
               <a:spcAft>
-                <a:spcPts val="1200"/>
+                <a:spcPts val="1000"/>
               </a:spcAft>
               <a:buSzPct val="100000"/>
               <a:buChar char="•"/>
             </a:pPr>
             <a:r>
-              <a:rPr lang="en-US" sz="1800" dirty="0">
+              <a:rPr lang="en-US" sz="1600" dirty="0">
                 <a:solidFill>
                   <a:srgbClr val="1F1A2E"/>
                 </a:solidFill>
@@ -4514,20 +4514,20 @@
                 <a:ea typeface="Calibri" pitchFamily="34" charset="-122"/>
                 <a:cs typeface="Calibri" pitchFamily="34" charset="-120"/>
               </a:rPr>
-              <a:t>Apoyo con lo digital</a:t>
-            </a:r>
-            <a:endParaRPr lang="en-US" sz="1800" dirty="0"/>
+              <a:t>100 %: mejorar la tecnología</a:t>
+            </a:r>
+            <a:endParaRPr lang="en-US" sz="1600" dirty="0"/>
           </a:p>
           <a:p>
             <a:pPr marL="342900" indent="-342900">
               <a:spcAft>
-                <a:spcPts val="1200"/>
+                <a:spcPts val="1000"/>
               </a:spcAft>
               <a:buSzPct val="100000"/>
               <a:buChar char="•"/>
             </a:pPr>
             <a:r>
-              <a:rPr lang="en-US" sz="1800" dirty="0">
+              <a:rPr lang="en-US" sz="1600" dirty="0">
                 <a:solidFill>
                   <a:srgbClr val="1F1A2E"/>
                 </a:solidFill>
@@ -4535,20 +4535,20 @@
                 <a:ea typeface="Calibri" pitchFamily="34" charset="-122"/>
                 <a:cs typeface="Calibri" pitchFamily="34" charset="-120"/>
               </a:rPr>
-              <a:t>Más tiempo para atender</a:t>
-            </a:r>
-            <a:endParaRPr lang="en-US" sz="1800" dirty="0"/>
+              <a:t>Valores y organigrama sin conocer</a:t>
+            </a:r>
+            <a:endParaRPr lang="en-US" sz="1600" dirty="0"/>
           </a:p>
           <a:p>
             <a:pPr marL="342900" indent="-342900">
               <a:spcAft>
-                <a:spcPts val="1200"/>
+                <a:spcPts val="1000"/>
               </a:spcAft>
               <a:buSzPct val="100000"/>
               <a:buChar char="•"/>
             </a:pPr>
             <a:r>
-              <a:rPr lang="en-US" sz="1800" dirty="0">
+              <a:rPr lang="en-US" sz="1600" dirty="0">
                 <a:solidFill>
                   <a:srgbClr val="1F1A2E"/>
                 </a:solidFill>
@@ -4558,28 +4558,7 @@
               </a:rPr>
               <a:t>Datos claros para decidir</a:t>
             </a:r>
-            <a:endParaRPr lang="en-US" sz="1800" dirty="0"/>
-          </a:p>
-          <a:p>
-            <a:pPr marL="342900" indent="-342900">
-              <a:spcAft>
-                <a:spcPts val="1200"/>
-              </a:spcAft>
-              <a:buSzPct val="100000"/>
-              <a:buChar char="•"/>
-            </a:pPr>
-            <a:r>
-              <a:rPr lang="en-US" sz="1800" dirty="0">
-                <a:solidFill>
-                  <a:srgbClr val="1F1A2E"/>
-                </a:solidFill>
-                <a:latin typeface="Calibri" pitchFamily="34" charset="0"/>
-                <a:ea typeface="Calibri" pitchFamily="34" charset="-122"/>
-                <a:cs typeface="Calibri" pitchFamily="34" charset="-120"/>
-              </a:rPr>
-              <a:t>Herramientas sencillas</a:t>
-            </a:r>
-            <a:endParaRPr lang="en-US" sz="1800" dirty="0"/>
+            <a:endParaRPr lang="en-US" sz="1600" dirty="0"/>
           </a:p>
         </p:txBody>
       </p:sp>
@@ -4591,12 +4570,12 @@
         </p:nvSpPr>
         <p:spPr>
           <a:xfrm>
-            <a:off x="6217920" y="1463040"/>
-            <a:ext cx="5394960" cy="4572000"/>
+            <a:off x="4343400" y="1463040"/>
+            <a:ext cx="3520440" cy="4572000"/>
           </a:xfrm>
           <a:prstGeom prst="roundRect">
             <a:avLst>
-              <a:gd name="adj" fmla="val 2400"/>
+              <a:gd name="adj" fmla="val 3117"/>
             </a:avLst>
           </a:prstGeom>
           <a:solidFill>
@@ -4625,7 +4604,7 @@
         </p:nvSpPr>
         <p:spPr>
           <a:xfrm>
-            <a:off x="6583680" y="1737360"/>
+            <a:off x="5623560" y="1691640"/>
             <a:ext cx="914400" cy="914400"/>
           </a:xfrm>
           <a:prstGeom prst="ellipse">
@@ -4658,7 +4637,7 @@
         </p:blipFill>
         <p:spPr>
           <a:xfrm>
-            <a:off x="6812280" y="1965960"/>
+            <a:off x="5852160" y="1920240"/>
             <a:ext cx="457200" cy="457200"/>
           </a:xfrm>
           <a:prstGeom prst="rect">
@@ -4674,8 +4653,8 @@
         </p:nvSpPr>
         <p:spPr>
           <a:xfrm>
-            <a:off x="7680960" y="1783080"/>
-            <a:ext cx="3657600" cy="457200"/>
+            <a:off x="4343400" y="2743200"/>
+            <a:ext cx="3520440" cy="457200"/>
           </a:xfrm>
           <a:prstGeom prst="rect">
             <a:avLst/>
@@ -4687,7 +4666,7 @@
           <a:bodyPr wrap="square" lIns="0" tIns="0" rIns="0" bIns="0" rtlCol="0" anchor="t"/>
           <a:lstStyle/>
           <a:p>
-            <a:pPr indent="0" marL="0">
+            <a:pPr algn="ctr" indent="0" marL="0">
               <a:buNone/>
             </a:pPr>
             <a:r>
@@ -4699,7 +4678,7 @@
                 <a:ea typeface="Cambria" pitchFamily="34" charset="-122"/>
                 <a:cs typeface="Cambria" pitchFamily="34" charset="-120"/>
               </a:rPr>
-              <a:t>Clientes externos</a:t>
+              <a:t>Externos</a:t>
             </a:r>
             <a:endParaRPr lang="en-US" sz="2400" dirty="0"/>
           </a:p>
@@ -4713,8 +4692,8 @@
         </p:nvSpPr>
         <p:spPr>
           <a:xfrm>
-            <a:off x="7680960" y="2267712"/>
-            <a:ext cx="3657600" cy="365760"/>
+            <a:off x="4343400" y="3200400"/>
+            <a:ext cx="3520440" cy="365760"/>
           </a:xfrm>
           <a:prstGeom prst="rect">
             <a:avLst/>
@@ -4726,11 +4705,11 @@
           <a:bodyPr wrap="square" lIns="0" tIns="0" rIns="0" bIns="0" rtlCol="0" anchor="t"/>
           <a:lstStyle/>
           <a:p>
-            <a:pPr indent="0" marL="0">
+            <a:pPr algn="ctr" indent="0" marL="0">
               <a:buNone/>
             </a:pPr>
             <a:r>
-              <a:rPr lang="en-US" sz="1500" i="1" dirty="0">
+              <a:rPr lang="en-US" sz="1400" i="1" dirty="0">
                 <a:solidFill>
                   <a:srgbClr val="555555"/>
                 </a:solidFill>
@@ -4738,9 +4717,9 @@
                 <a:ea typeface="Calibri" pitchFamily="34" charset="-122"/>
                 <a:cs typeface="Calibri" pitchFamily="34" charset="-120"/>
               </a:rPr>
-              <a:t>Las clientas de Yopal</a:t>
-            </a:r>
-            <a:endParaRPr lang="en-US" sz="1500" dirty="0"/>
+              <a:t>45 clientas encuestadas</a:t>
+            </a:r>
+            <a:endParaRPr lang="en-US" sz="1400" dirty="0"/>
           </a:p>
         </p:txBody>
       </p:sp>
@@ -4752,8 +4731,8 @@
         </p:nvSpPr>
         <p:spPr>
           <a:xfrm>
-            <a:off x="6675120" y="3017520"/>
-            <a:ext cx="4572000" cy="2743200"/>
+            <a:off x="4617720" y="3794760"/>
+            <a:ext cx="3017520" cy="2103120"/>
           </a:xfrm>
           <a:prstGeom prst="rect">
             <a:avLst/>
@@ -4767,13 +4746,13 @@
           <a:p>
             <a:pPr marL="342900" indent="-342900">
               <a:spcAft>
-                <a:spcPts val="1200"/>
+                <a:spcPts val="1000"/>
               </a:spcAft>
               <a:buSzPct val="100000"/>
               <a:buChar char="•"/>
             </a:pPr>
             <a:r>
-              <a:rPr lang="en-US" sz="1800" dirty="0">
+              <a:rPr lang="en-US" sz="1600" dirty="0">
                 <a:solidFill>
                   <a:srgbClr val="1F1A2E"/>
                 </a:solidFill>
@@ -4781,20 +4760,20 @@
                 <a:ea typeface="Calibri" pitchFamily="34" charset="-122"/>
                 <a:cs typeface="Calibri" pitchFamily="34" charset="-120"/>
               </a:rPr>
-              <a:t>Ver productos y precios antes de ir</a:t>
-            </a:r>
-            <a:endParaRPr lang="en-US" sz="1800" dirty="0"/>
+              <a:t>Estilo, buen precio y atención</a:t>
+            </a:r>
+            <a:endParaRPr lang="en-US" sz="1600" dirty="0"/>
           </a:p>
           <a:p>
             <a:pPr marL="342900" indent="-342900">
               <a:spcAft>
-                <a:spcPts val="1200"/>
+                <a:spcPts val="1000"/>
               </a:spcAft>
               <a:buSzPct val="100000"/>
               <a:buChar char="•"/>
             </a:pPr>
             <a:r>
-              <a:rPr lang="en-US" sz="1800" dirty="0">
+              <a:rPr lang="en-US" sz="1600" dirty="0">
                 <a:solidFill>
                   <a:srgbClr val="1F1A2E"/>
                 </a:solidFill>
@@ -4802,20 +4781,20 @@
                 <a:ea typeface="Calibri" pitchFamily="34" charset="-122"/>
                 <a:cs typeface="Calibri" pitchFamily="34" charset="-120"/>
               </a:rPr>
-              <a:t>Respuesta rápida por WhatsApp</a:t>
-            </a:r>
-            <a:endParaRPr lang="en-US" sz="1800" dirty="0"/>
+              <a:t>Ver productos en redes</a:t>
+            </a:r>
+            <a:endParaRPr lang="en-US" sz="1600" dirty="0"/>
           </a:p>
           <a:p>
             <a:pPr marL="342900" indent="-342900">
               <a:spcAft>
-                <a:spcPts val="1200"/>
+                <a:spcPts val="1000"/>
               </a:spcAft>
               <a:buSzPct val="100000"/>
               <a:buChar char="•"/>
             </a:pPr>
             <a:r>
-              <a:rPr lang="en-US" sz="1800" dirty="0">
+              <a:rPr lang="en-US" sz="1600" dirty="0">
                 <a:solidFill>
                   <a:srgbClr val="1F1A2E"/>
                 </a:solidFill>
@@ -4823,20 +4802,203 @@
                 <a:ea typeface="Calibri" pitchFamily="34" charset="-122"/>
                 <a:cs typeface="Calibri" pitchFamily="34" charset="-120"/>
               </a:rPr>
-              <a:t>Domicilio y asesoría</a:t>
-            </a:r>
-            <a:endParaRPr lang="en-US" sz="1800" dirty="0"/>
-          </a:p>
+              <a:t>Respuesta rápida y domicilio</a:t>
+            </a:r>
+            <a:endParaRPr lang="en-US" sz="1600" dirty="0"/>
+          </a:p>
+        </p:txBody>
+      </p:sp>
+      <p:sp>
+        <p:nvSpPr>
+          <p:cNvPr id="15" name="Shape 11"/>
+          <p:cNvSpPr/>
+          <p:nvPr/>
+        </p:nvSpPr>
+        <p:spPr>
+          <a:xfrm>
+            <a:off x="8138160" y="1463040"/>
+            <a:ext cx="3520440" cy="4572000"/>
+          </a:xfrm>
+          <a:prstGeom prst="roundRect">
+            <a:avLst>
+              <a:gd name="adj" fmla="val 3117"/>
+            </a:avLst>
+          </a:prstGeom>
+          <a:solidFill>
+            <a:srgbClr val="EFE8FA"/>
+          </a:solidFill>
+          <a:ln w="12700">
+            <a:solidFill>
+              <a:srgbClr val="EFE8FA"/>
+            </a:solidFill>
+            <a:prstDash val="solid"/>
+          </a:ln>
+          <a:effectLst>
+            <a:outerShdw sx="100000" sy="100000" kx="0" ky="0" algn="bl" rotWithShape="0" blurRad="76200" dist="25400" dir="5400000">
+              <a:srgbClr val="000000">
+                <a:alpha val="12000"/>
+              </a:srgbClr>
+            </a:outerShdw>
+          </a:effectLst>
+        </p:spPr>
+      </p:sp>
+      <p:sp>
+        <p:nvSpPr>
+          <p:cNvPr id="16" name="Shape 12"/>
+          <p:cNvSpPr/>
+          <p:nvPr/>
+        </p:nvSpPr>
+        <p:spPr>
+          <a:xfrm>
+            <a:off x="9418320" y="1691640"/>
+            <a:ext cx="914400" cy="914400"/>
+          </a:xfrm>
+          <a:prstGeom prst="ellipse">
+            <a:avLst/>
+          </a:prstGeom>
+          <a:solidFill>
+            <a:srgbClr val="2F9A6A"/>
+          </a:solidFill>
+          <a:ln w="12700">
+            <a:solidFill>
+              <a:srgbClr val="2F9A6A"/>
+            </a:solidFill>
+            <a:prstDash val="solid"/>
+          </a:ln>
+        </p:spPr>
+      </p:sp>
+      <p:pic>
+        <p:nvPicPr>
+          <p:cNvPr id="17" name="Image 2" descr="preencoded.png">    </p:cNvPr>
+          <p:cNvPicPr>
+            <a:picLocks noChangeAspect="1"/>
+          </p:cNvPicPr>
+          <p:nvPr/>
+        </p:nvPicPr>
+        <p:blipFill>
+          <a:blip r:embed="rId3"/>
+          <a:stretch>
+            <a:fillRect/>
+          </a:stretch>
+        </p:blipFill>
+        <p:spPr>
+          <a:xfrm>
+            <a:off x="9646920" y="1920240"/>
+            <a:ext cx="457200" cy="457200"/>
+          </a:xfrm>
+          <a:prstGeom prst="rect">
+            <a:avLst/>
+          </a:prstGeom>
+        </p:spPr>
+      </p:pic>
+      <p:sp>
+        <p:nvSpPr>
+          <p:cNvPr id="18" name="Text 13"/>
+          <p:cNvSpPr txBox="1"/>
+          <p:nvPr/>
+        </p:nvSpPr>
+        <p:spPr>
+          <a:xfrm>
+            <a:off x="8138160" y="2743200"/>
+            <a:ext cx="3520440" cy="457200"/>
+          </a:xfrm>
+          <a:prstGeom prst="rect">
+            <a:avLst/>
+          </a:prstGeom>
+          <a:noFill/>
+          <a:ln/>
+        </p:spPr>
+        <p:txBody>
+          <a:bodyPr wrap="square" lIns="0" tIns="0" rIns="0" bIns="0" rtlCol="0" anchor="t"/>
+          <a:lstStyle/>
+          <a:p>
+            <a:pPr algn="ctr" indent="0" marL="0">
+              <a:buNone/>
+            </a:pPr>
+            <a:r>
+              <a:rPr lang="en-US" sz="2400" b="1" dirty="0">
+                <a:solidFill>
+                  <a:srgbClr val="2F9A6A"/>
+                </a:solidFill>
+                <a:latin typeface="Cambria" pitchFamily="34" charset="0"/>
+                <a:ea typeface="Cambria" pitchFamily="34" charset="-122"/>
+                <a:cs typeface="Cambria" pitchFamily="34" charset="-120"/>
+              </a:rPr>
+              <a:t>Proveedores</a:t>
+            </a:r>
+            <a:endParaRPr lang="en-US" sz="2400" dirty="0"/>
+          </a:p>
+        </p:txBody>
+      </p:sp>
+      <p:sp>
+        <p:nvSpPr>
+          <p:cNvPr id="19" name="Text 14"/>
+          <p:cNvSpPr txBox="1"/>
+          <p:nvPr/>
+        </p:nvSpPr>
+        <p:spPr>
+          <a:xfrm>
+            <a:off x="8138160" y="3200400"/>
+            <a:ext cx="3520440" cy="365760"/>
+          </a:xfrm>
+          <a:prstGeom prst="rect">
+            <a:avLst/>
+          </a:prstGeom>
+          <a:noFill/>
+          <a:ln/>
+        </p:spPr>
+        <p:txBody>
+          <a:bodyPr wrap="square" lIns="0" tIns="0" rIns="0" bIns="0" rtlCol="0" anchor="t"/>
+          <a:lstStyle/>
+          <a:p>
+            <a:pPr algn="ctr" indent="0" marL="0">
+              <a:buNone/>
+            </a:pPr>
+            <a:r>
+              <a:rPr lang="en-US" sz="1400" i="1" dirty="0">
+                <a:solidFill>
+                  <a:srgbClr val="555555"/>
+                </a:solidFill>
+                <a:latin typeface="Calibri" pitchFamily="34" charset="0"/>
+                <a:ea typeface="Calibri" pitchFamily="34" charset="-122"/>
+                <a:cs typeface="Calibri" pitchFamily="34" charset="-120"/>
+              </a:rPr>
+              <a:t>5 proveedores encuestados</a:t>
+            </a:r>
+            <a:endParaRPr lang="en-US" sz="1400" dirty="0"/>
+          </a:p>
+        </p:txBody>
+      </p:sp>
+      <p:sp>
+        <p:nvSpPr>
+          <p:cNvPr id="20" name="Text 15"/>
+          <p:cNvSpPr txBox="1"/>
+          <p:nvPr/>
+        </p:nvSpPr>
+        <p:spPr>
+          <a:xfrm>
+            <a:off x="8412480" y="3794760"/>
+            <a:ext cx="3017520" cy="2103120"/>
+          </a:xfrm>
+          <a:prstGeom prst="rect">
+            <a:avLst/>
+          </a:prstGeom>
+          <a:noFill/>
+          <a:ln/>
+        </p:spPr>
+        <p:txBody>
+          <a:bodyPr wrap="square" lIns="0" tIns="0" rIns="0" bIns="0" rtlCol="0" anchor="t"/>
+          <a:lstStyle/>
           <a:p>
             <a:pPr marL="342900" indent="-342900">
               <a:spcAft>
-                <a:spcPts val="1200"/>
+                <a:spcPts val="1000"/>
               </a:spcAft>
               <a:buSzPct val="100000"/>
               <a:buChar char="•"/>
             </a:pPr>
             <a:r>
-              <a:rPr lang="en-US" sz="1800" dirty="0">
+              <a:rPr lang="en-US" sz="1600" dirty="0">
                 <a:solidFill>
                   <a:srgbClr val="1F1A2E"/>
                 </a:solidFill>
@@ -4844,9 +5006,51 @@
                 <a:ea typeface="Calibri" pitchFamily="34" charset="-122"/>
                 <a:cs typeface="Calibri" pitchFamily="34" charset="-120"/>
               </a:rPr>
-              <a:t>Novedades y promociones</a:t>
-            </a:r>
-            <a:endParaRPr lang="en-US" sz="1800" dirty="0"/>
+              <a:t>Comunicación más ágil</a:t>
+            </a:r>
+            <a:endParaRPr lang="en-US" sz="1600" dirty="0"/>
+          </a:p>
+          <a:p>
+            <a:pPr marL="342900" indent="-342900">
+              <a:spcAft>
+                <a:spcPts val="1000"/>
+              </a:spcAft>
+              <a:buSzPct val="100000"/>
+              <a:buChar char="•"/>
+            </a:pPr>
+            <a:r>
+              <a:rPr lang="en-US" sz="1600" dirty="0">
+                <a:solidFill>
+                  <a:srgbClr val="1F1A2E"/>
+                </a:solidFill>
+                <a:latin typeface="Calibri" pitchFamily="34" charset="0"/>
+                <a:ea typeface="Calibri" pitchFamily="34" charset="-122"/>
+                <a:cs typeface="Calibri" pitchFamily="34" charset="-120"/>
+              </a:rPr>
+              <a:t>Retroalimentación (60 %: a veces)</a:t>
+            </a:r>
+            <a:endParaRPr lang="en-US" sz="1600" dirty="0"/>
+          </a:p>
+          <a:p>
+            <a:pPr marL="342900" indent="-342900">
+              <a:spcAft>
+                <a:spcPts val="1000"/>
+              </a:spcAft>
+              <a:buSzPct val="100000"/>
+              <a:buChar char="•"/>
+            </a:pPr>
+            <a:r>
+              <a:rPr lang="en-US" sz="1600" dirty="0">
+                <a:solidFill>
+                  <a:srgbClr val="1F1A2E"/>
+                </a:solidFill>
+                <a:latin typeface="Calibri" pitchFamily="34" charset="0"/>
+                <a:ea typeface="Calibri" pitchFamily="34" charset="-122"/>
+                <a:cs typeface="Calibri" pitchFamily="34" charset="-120"/>
+              </a:rPr>
+              <a:t>Compras planeadas con datos</a:t>
+            </a:r>
+            <a:endParaRPr lang="en-US" sz="1600" dirty="0"/>
           </a:p>
         </p:txBody>
       </p:sp>
@@ -5113,7 +5317,7 @@
                 <a:ea typeface="Calibri" pitchFamily="34" charset="-122"/>
                 <a:cs typeface="Calibri" pitchFamily="34" charset="-120"/>
               </a:rPr>
-              <a:t>15 % en 5 prendas quietas, solo ese día.</a:t>
+              <a:t>15 % en 5 prendas quietas: mueve un día flojo.</a:t>
             </a:r>
             <a:endParaRPr lang="en-US" sz="1500" dirty="0"/>
           </a:p>
@@ -5557,7 +5761,7 @@
                 <a:ea typeface="Calibri" pitchFamily="34" charset="-122"/>
                 <a:cs typeface="Calibri" pitchFamily="34" charset="-120"/>
               </a:rPr>
-              <a:t>Combos Hechizo</a:t>
+              <a:t>Portafolio digital</a:t>
             </a:r>
             <a:endParaRPr lang="en-US" sz="1800" dirty="0"/>
           </a:p>
@@ -5596,7 +5800,7 @@
                 <a:ea typeface="Calibri" pitchFamily="34" charset="-122"/>
                 <a:cs typeface="Calibri" pitchFamily="34" charset="-120"/>
               </a:rPr>
-              <a:t>Prenda + perfume con un regalo.</a:t>
+              <a:t>Catálogo de ropa, perfumes y correas con precios.</a:t>
             </a:r>
             <a:endParaRPr lang="en-US" sz="1500" dirty="0"/>
           </a:p>
@@ -7034,7 +7238,7 @@
                 <a:ea typeface="Calibri" pitchFamily="34" charset="-122"/>
                 <a:cs typeface="Calibri" pitchFamily="34" charset="-120"/>
               </a:rPr>
-              <a:t>Black Friday</a:t>
+              <a:t>Black Friday y diciembre</a:t>
             </a:r>
             <a:endParaRPr lang="en-US" sz="1500" dirty="0"/>
           </a:p>
@@ -7055,7 +7259,7 @@
                 <a:ea typeface="Calibri" pitchFamily="34" charset="-122"/>
                 <a:cs typeface="Calibri" pitchFamily="34" charset="-120"/>
               </a:rPr>
-              <a:t>Temporada de diciembre</a:t>
+              <a:t>Sistema de inventario y POS</a:t>
             </a:r>
             <a:endParaRPr lang="en-US" sz="1500" dirty="0"/>
           </a:p>

</xml_diff>

<commit_message>
Corregir dueño y personal de Luna de Cristal en todos los archivos
Co-Authored-By: Claude Opus 5.5 <noreply@anthropic.com>
Claude-Session: https://claude.ai/code/session_01P9bj8o7UcwbCu86Zsog7Lb
</commit_message>
<xml_diff>
--- a/Actividad Alva instructora Luna de Cristal/4_Paso4_Visual_Thinking.pptx
+++ b/Actividad Alva instructora Luna de Cristal/4_Paso4_Visual_Thinking.pptx
@@ -115,31 +115,31 @@
   <p:extLst>
     <p:ext uri="{521415D9-36F7-43E2-AB2F-B90AF26B5E84}">
       <p14:sectionLst xmlns:p14="http://schemas.microsoft.com/office/powerpoint/2010/main">
-        <p14:section name="Inicio" id="{69b68b68-ca8a-b276-f5aa-2a8647f7a240}">
+        <p14:section name="Inicio" id="{26ada13f-310c-e170-c4cb-fc1586cbcb77}">
           <p14:sldIdLst>
             <p14:sldId id="256"/>
           </p14:sldIdLst>
         </p14:section>
-        <p14:section name="Diagnóstico" id="{530b8d97-0ee3-dd76-aded-0ffe4011b801}">
+        <p14:section name="Diagnóstico" id="{b5d7b0f6-2c53-ce1c-e8c1-c77924de1ed2}">
           <p14:sldIdLst>
             <p14:sldId id="257"/>
             <p14:sldId id="258"/>
             <p14:sldId id="259"/>
           </p14:sldIdLst>
         </p14:section>
-        <p14:section name="Análisis" id="{8f34badc-0161-5319-3a90-164cb64e769f}">
+        <p14:section name="Análisis" id="{cc041eee-fc40-4e10-1e54-ce2ca2c5a4a1}">
           <p14:sldIdLst>
             <p14:sldId id="260"/>
             <p14:sldId id="261"/>
           </p14:sldIdLst>
         </p14:section>
-        <p14:section name="Innovación" id="{f930c74a-f58e-4618-575c-133779c61825}">
+        <p14:section name="Innovación" id="{93a9d1a7-de5c-7173-1f99-3d3edbd5a521}">
           <p14:sldIdLst>
             <p14:sldId id="262"/>
             <p14:sldId id="263"/>
           </p14:sldIdLst>
         </p14:section>
-        <p14:section name="Cierre" id="{7de344fe-abe8-9714-ea92-4364f567840b}">
+        <p14:section name="Cierre" id="{c29952ec-b7b7-4b59-7f7f-c2fe21c35ce9}">
           <p14:sldIdLst>
             <p14:sldId id="264"/>
           </p14:sldIdLst>
@@ -2335,7 +2335,7 @@
                 <a:ea typeface="Calibri" pitchFamily="34" charset="-122"/>
                 <a:cs typeface="Calibri" pitchFamily="34" charset="-120"/>
               </a:rPr>
-              <a:t>Cra 19 # 23-57, centro de Yopal. Propietaria y un asesor de ventas.</a:t>
+              <a:t>Cra 19 # 23-57, Yopal. Dueño: Sebastián. Atienden su mamá (administra) y una prima.</a:t>
             </a:r>
             <a:endParaRPr lang="en-US" sz="1400" dirty="0"/>
           </a:p>
@@ -4471,7 +4471,7 @@
                 <a:ea typeface="Calibri" pitchFamily="34" charset="-122"/>
                 <a:cs typeface="Calibri" pitchFamily="34" charset="-120"/>
               </a:rPr>
-              <a:t>Propietaria y asesor</a:t>
+              <a:t>Administradora y prima</a:t>
             </a:r>
             <a:endParaRPr lang="en-US" sz="1400" dirty="0"/>
           </a:p>

</xml_diff>